<commit_message>
Update slides with real chart images from live data run
10 chart PNGs now embedded in slides (was placeholders):
- Slide 2: Price overlay (NVDA vs CSCO)
- Slide 5: P/E trajectory
- Slide 6: Revenue growth comparison
- Slide 7: Concentration timeline + SPY vs RSP (2 images)
- Slide 8: AI mentions + hype vs specificity (2 images)
- Slide 9: Macro dashboard
- Slide 10: Regime classification
- Slide 11: DTW similarity

Zero placeholders remain in main presentation (slides 1-15).

Co-Authored-By: Claude Opus 4.6 (1M context) <noreply@anthropic.com>
</commit_message>
<xml_diff>
--- a/submissions/2kim_finance_slides.pptx
+++ b/submissions/2kim_finance_slides.pptx
@@ -3397,65 +3397,30 @@
           </a:p>
         </p:txBody>
       </p:sp>
-      <p:sp>
-        <p:nvSpPr>
-          <p:cNvPr id="3" name="Rounded Rectangle 2"/>
-          <p:cNvSpPr/>
-          <p:nvPr/>
-        </p:nvSpPr>
+      <p:pic>
+        <p:nvPicPr>
+          <p:cNvPr id="3" name="Picture 2" descr="chart_ml_1_regime_probabilities.png"/>
+          <p:cNvPicPr>
+            <a:picLocks noChangeAspect="1"/>
+          </p:cNvPicPr>
+          <p:nvPr/>
+        </p:nvPicPr>
+        <p:blipFill>
+          <a:blip r:embed="rId2"/>
+          <a:stretch>
+            <a:fillRect/>
+          </a:stretch>
+        </p:blipFill>
         <p:spPr>
           <a:xfrm>
             <a:off x="457200" y="1188720"/>
             <a:ext cx="7772400" cy="4754880"/>
           </a:xfrm>
-          <a:prstGeom prst="roundRect">
-            <a:avLst/>
-          </a:prstGeom>
-          <a:solidFill>
-            <a:srgbClr val="0D1117"/>
-          </a:solidFill>
-          <a:ln w="12700">
-            <a:solidFill>
-              <a:srgbClr val="374151"/>
-            </a:solidFill>
-          </a:ln>
-          <a:effectLst/>
-        </p:spPr>
-        <p:style>
-          <a:lnRef idx="1">
-            <a:schemeClr val="accent1"/>
-          </a:lnRef>
-          <a:fillRef idx="3">
-            <a:schemeClr val="accent1"/>
-          </a:fillRef>
-          <a:effectRef idx="2">
-            <a:schemeClr val="accent1"/>
-          </a:effectRef>
-          <a:fontRef idx="minor">
-            <a:schemeClr val="lt1"/>
-          </a:fontRef>
-        </p:style>
-        <p:txBody>
-          <a:bodyPr rtlCol="0" anchor="ctr" wrap="square"/>
-          <a:lstStyle/>
-          <a:p>
-            <a:pPr algn="ctr">
-              <a:spcBef>
-                <a:spcPts val="13000"/>
-              </a:spcBef>
-              <a:defRPr sz="1400">
-                <a:solidFill>
-                  <a:srgbClr val="6B7280"/>
-                </a:solidFill>
-                <a:latin typeface="Calibri"/>
-              </a:defRPr>
-            </a:pPr>
-            <a:r>
-              <a:t>[Chart ML.1 — Regime Classification Probabilities (stacked area)]</a:t>
-            </a:r>
-          </a:p>
-        </p:txBody>
-      </p:sp>
+          <a:prstGeom prst="rect">
+            <a:avLst/>
+          </a:prstGeom>
+        </p:spPr>
+      </p:pic>
       <p:sp>
         <p:nvSpPr>
           <p:cNvPr id="4" name="Rounded Rectangle 3"/>
@@ -3996,65 +3961,30 @@
           </a:p>
         </p:txBody>
       </p:sp>
-      <p:sp>
-        <p:nvSpPr>
-          <p:cNvPr id="3" name="Rounded Rectangle 2"/>
-          <p:cNvSpPr/>
-          <p:nvPr/>
-        </p:nvSpPr>
+      <p:pic>
+        <p:nvPicPr>
+          <p:cNvPr id="3" name="Picture 2" descr="chart_ml_2_dtw_similarity.png"/>
+          <p:cNvPicPr>
+            <a:picLocks noChangeAspect="1"/>
+          </p:cNvPicPr>
+          <p:nvPr/>
+        </p:nvPicPr>
+        <p:blipFill>
+          <a:blip r:embed="rId2"/>
+          <a:stretch>
+            <a:fillRect/>
+          </a:stretch>
+        </p:blipFill>
         <p:spPr>
           <a:xfrm>
             <a:off x="457200" y="1097280"/>
             <a:ext cx="11247120" cy="2286000"/>
           </a:xfrm>
-          <a:prstGeom prst="roundRect">
-            <a:avLst/>
-          </a:prstGeom>
-          <a:solidFill>
-            <a:srgbClr val="0D1117"/>
-          </a:solidFill>
-          <a:ln w="12700">
-            <a:solidFill>
-              <a:srgbClr val="374151"/>
-            </a:solidFill>
-          </a:ln>
-          <a:effectLst/>
-        </p:spPr>
-        <p:style>
-          <a:lnRef idx="1">
-            <a:schemeClr val="accent1"/>
-          </a:lnRef>
-          <a:fillRef idx="3">
-            <a:schemeClr val="accent1"/>
-          </a:fillRef>
-          <a:effectRef idx="2">
-            <a:schemeClr val="accent1"/>
-          </a:effectRef>
-          <a:fontRef idx="minor">
-            <a:schemeClr val="lt1"/>
-          </a:fontRef>
-        </p:style>
-        <p:txBody>
-          <a:bodyPr rtlCol="0" anchor="ctr" wrap="square"/>
-          <a:lstStyle/>
-          <a:p>
-            <a:pPr algn="ctr">
-              <a:spcBef>
-                <a:spcPts val="6250"/>
-              </a:spcBef>
-              <a:defRPr sz="1400">
-                <a:solidFill>
-                  <a:srgbClr val="6B7280"/>
-                </a:solidFill>
-                <a:latin typeface="Calibri"/>
-              </a:defRPr>
-            </a:pPr>
-            <a:r>
-              <a:t>[Chart ML.2 — DTW Similarity Timeline (rolling monthly score)]</a:t>
-            </a:r>
-          </a:p>
-        </p:txBody>
-      </p:sp>
+          <a:prstGeom prst="rect">
+            <a:avLst/>
+          </a:prstGeom>
+        </p:spPr>
+      </p:pic>
       <p:sp>
         <p:nvSpPr>
           <p:cNvPr id="4" name="Rounded Rectangle 3"/>
@@ -6415,65 +6345,30 @@
           </a:p>
         </p:txBody>
       </p:sp>
-      <p:sp>
-        <p:nvSpPr>
-          <p:cNvPr id="3" name="Rounded Rectangle 2"/>
-          <p:cNvSpPr/>
-          <p:nvPr/>
-        </p:nvSpPr>
+      <p:pic>
+        <p:nvPicPr>
+          <p:cNvPr id="3" name="Picture 2" descr="chart_1_1.png"/>
+          <p:cNvPicPr>
+            <a:picLocks noChangeAspect="1"/>
+          </p:cNvPicPr>
+          <p:nvPr/>
+        </p:nvPicPr>
+        <p:blipFill>
+          <a:blip r:embed="rId2"/>
+          <a:stretch>
+            <a:fillRect/>
+          </a:stretch>
+        </p:blipFill>
         <p:spPr>
           <a:xfrm>
             <a:off x="457200" y="1188720"/>
             <a:ext cx="11247120" cy="4754880"/>
           </a:xfrm>
-          <a:prstGeom prst="roundRect">
-            <a:avLst/>
-          </a:prstGeom>
-          <a:solidFill>
-            <a:srgbClr val="0D1117"/>
-          </a:solidFill>
-          <a:ln w="12700">
-            <a:solidFill>
-              <a:srgbClr val="374151"/>
-            </a:solidFill>
-          </a:ln>
-          <a:effectLst/>
-        </p:spPr>
-        <p:style>
-          <a:lnRef idx="1">
-            <a:schemeClr val="accent1"/>
-          </a:lnRef>
-          <a:fillRef idx="3">
-            <a:schemeClr val="accent1"/>
-          </a:fillRef>
-          <a:effectRef idx="2">
-            <a:schemeClr val="accent1"/>
-          </a:effectRef>
-          <a:fontRef idx="minor">
-            <a:schemeClr val="lt1"/>
-          </a:fontRef>
-        </p:style>
-        <p:txBody>
-          <a:bodyPr rtlCol="0" anchor="ctr" wrap="square"/>
-          <a:lstStyle/>
-          <a:p>
-            <a:pPr algn="ctr">
-              <a:spcBef>
-                <a:spcPts val="13000"/>
-              </a:spcBef>
-              <a:defRPr sz="1400">
-                <a:solidFill>
-                  <a:srgbClr val="6B7280"/>
-                </a:solidFill>
-                <a:latin typeface="Calibri"/>
-              </a:defRPr>
-            </a:pPr>
-            <a:r>
-              <a:t>[Chart 1.1 — Normalized Price Overlay: NVDA (green) vs CSCO (red) vs Nortel (gray dashed)]</a:t>
-            </a:r>
-          </a:p>
-        </p:txBody>
-      </p:sp>
+          <a:prstGeom prst="rect">
+            <a:avLst/>
+          </a:prstGeom>
+        </p:spPr>
+      </p:pic>
       <p:sp>
         <p:nvSpPr>
           <p:cNvPr id="4" name="TextBox 3"/>
@@ -8090,65 +7985,30 @@
           </a:p>
         </p:txBody>
       </p:sp>
-      <p:sp>
-        <p:nvSpPr>
-          <p:cNvPr id="3" name="Rounded Rectangle 2"/>
-          <p:cNvSpPr/>
-          <p:nvPr/>
-        </p:nvSpPr>
+      <p:pic>
+        <p:nvPicPr>
+          <p:cNvPr id="3" name="Picture 2" descr="chart_2_1_pe_trajectory.png"/>
+          <p:cNvPicPr>
+            <a:picLocks noChangeAspect="1"/>
+          </p:cNvPicPr>
+          <p:nvPr/>
+        </p:nvPicPr>
+        <p:blipFill>
+          <a:blip r:embed="rId2"/>
+          <a:stretch>
+            <a:fillRect/>
+          </a:stretch>
+        </p:blipFill>
         <p:spPr>
           <a:xfrm>
             <a:off x="457200" y="1188720"/>
             <a:ext cx="7315200" cy="4754880"/>
           </a:xfrm>
-          <a:prstGeom prst="roundRect">
-            <a:avLst/>
-          </a:prstGeom>
-          <a:solidFill>
-            <a:srgbClr val="0D1117"/>
-          </a:solidFill>
-          <a:ln w="12700">
-            <a:solidFill>
-              <a:srgbClr val="374151"/>
-            </a:solidFill>
-          </a:ln>
-          <a:effectLst/>
-        </p:spPr>
-        <p:style>
-          <a:lnRef idx="1">
-            <a:schemeClr val="accent1"/>
-          </a:lnRef>
-          <a:fillRef idx="3">
-            <a:schemeClr val="accent1"/>
-          </a:fillRef>
-          <a:effectRef idx="2">
-            <a:schemeClr val="accent1"/>
-          </a:effectRef>
-          <a:fontRef idx="minor">
-            <a:schemeClr val="lt1"/>
-          </a:fontRef>
-        </p:style>
-        <p:txBody>
-          <a:bodyPr rtlCol="0" anchor="ctr" wrap="square"/>
-          <a:lstStyle/>
-          <a:p>
-            <a:pPr algn="ctr">
-              <a:spcBef>
-                <a:spcPts val="13000"/>
-              </a:spcBef>
-              <a:defRPr sz="1400">
-                <a:solidFill>
-                  <a:srgbClr val="6B7280"/>
-                </a:solidFill>
-                <a:latin typeface="Calibri"/>
-              </a:defRPr>
-            </a:pPr>
-            <a:r>
-              <a:t>[Chart 2.1 — P/E Ratio Trajectory: NVDA vs CSCO aligned by cycle phase]</a:t>
-            </a:r>
-          </a:p>
-        </p:txBody>
-      </p:sp>
+          <a:prstGeom prst="rect">
+            <a:avLst/>
+          </a:prstGeom>
+        </p:spPr>
+      </p:pic>
       <p:sp>
         <p:nvSpPr>
           <p:cNvPr id="4" name="Rounded Rectangle 3"/>
@@ -8545,65 +8405,30 @@
           </a:p>
         </p:txBody>
       </p:sp>
-      <p:sp>
-        <p:nvSpPr>
-          <p:cNvPr id="3" name="Rounded Rectangle 2"/>
-          <p:cNvSpPr/>
-          <p:nvPr/>
-        </p:nvSpPr>
+      <p:pic>
+        <p:nvPicPr>
+          <p:cNvPr id="3" name="Picture 2" descr="chart_2_2_revenue_growth.png"/>
+          <p:cNvPicPr>
+            <a:picLocks noChangeAspect="1"/>
+          </p:cNvPicPr>
+          <p:nvPr/>
+        </p:nvPicPr>
+        <p:blipFill>
+          <a:blip r:embed="rId2"/>
+          <a:stretch>
+            <a:fillRect/>
+          </a:stretch>
+        </p:blipFill>
         <p:spPr>
           <a:xfrm>
             <a:off x="457200" y="1188720"/>
             <a:ext cx="11247120" cy="3657600"/>
           </a:xfrm>
-          <a:prstGeom prst="roundRect">
-            <a:avLst/>
-          </a:prstGeom>
-          <a:solidFill>
-            <a:srgbClr val="0D1117"/>
-          </a:solidFill>
-          <a:ln w="12700">
-            <a:solidFill>
-              <a:srgbClr val="374151"/>
-            </a:solidFill>
-          </a:ln>
-          <a:effectLst/>
-        </p:spPr>
-        <p:style>
-          <a:lnRef idx="1">
-            <a:schemeClr val="accent1"/>
-          </a:lnRef>
-          <a:fillRef idx="3">
-            <a:schemeClr val="accent1"/>
-          </a:fillRef>
-          <a:effectRef idx="2">
-            <a:schemeClr val="accent1"/>
-          </a:effectRef>
-          <a:fontRef idx="minor">
-            <a:schemeClr val="lt1"/>
-          </a:fontRef>
-        </p:style>
-        <p:txBody>
-          <a:bodyPr rtlCol="0" anchor="ctr" wrap="square"/>
-          <a:lstStyle/>
-          <a:p>
-            <a:pPr algn="ctr">
-              <a:spcBef>
-                <a:spcPts val="10000"/>
-              </a:spcBef>
-              <a:defRPr sz="1400">
-                <a:solidFill>
-                  <a:srgbClr val="6B7280"/>
-                </a:solidFill>
-                <a:latin typeface="Calibri"/>
-              </a:defRPr>
-            </a:pPr>
-            <a:r>
-              <a:t>[Chart 2.2 — Revenue Growth Rate Comparison: NVDA (green bars) vs CSCO (red bars)]</a:t>
-            </a:r>
-          </a:p>
-        </p:txBody>
-      </p:sp>
+          <a:prstGeom prst="rect">
+            <a:avLst/>
+          </a:prstGeom>
+        </p:spPr>
+      </p:pic>
       <p:sp>
         <p:nvSpPr>
           <p:cNvPr id="4" name="TextBox 3"/>
@@ -8846,124 +8671,54 @@
           </a:p>
         </p:txBody>
       </p:sp>
-      <p:sp>
-        <p:nvSpPr>
-          <p:cNvPr id="3" name="Rounded Rectangle 2"/>
-          <p:cNvSpPr/>
-          <p:nvPr/>
-        </p:nvSpPr>
+      <p:pic>
+        <p:nvPicPr>
+          <p:cNvPr id="3" name="Picture 2" descr="chart_3_1_concentration_timeline.png"/>
+          <p:cNvPicPr>
+            <a:picLocks noChangeAspect="1"/>
+          </p:cNvPicPr>
+          <p:nvPr/>
+        </p:nvPicPr>
+        <p:blipFill>
+          <a:blip r:embed="rId2"/>
+          <a:stretch>
+            <a:fillRect/>
+          </a:stretch>
+        </p:blipFill>
         <p:spPr>
           <a:xfrm>
             <a:off x="457200" y="1188720"/>
             <a:ext cx="6858000" cy="4754880"/>
           </a:xfrm>
-          <a:prstGeom prst="roundRect">
-            <a:avLst/>
-          </a:prstGeom>
-          <a:solidFill>
-            <a:srgbClr val="0D1117"/>
-          </a:solidFill>
-          <a:ln w="12700">
-            <a:solidFill>
-              <a:srgbClr val="374151"/>
-            </a:solidFill>
-          </a:ln>
-          <a:effectLst/>
-        </p:spPr>
-        <p:style>
-          <a:lnRef idx="1">
-            <a:schemeClr val="accent1"/>
-          </a:lnRef>
-          <a:fillRef idx="3">
-            <a:schemeClr val="accent1"/>
-          </a:fillRef>
-          <a:effectRef idx="2">
-            <a:schemeClr val="accent1"/>
-          </a:effectRef>
-          <a:fontRef idx="minor">
-            <a:schemeClr val="lt1"/>
-          </a:fontRef>
-        </p:style>
-        <p:txBody>
-          <a:bodyPr rtlCol="0" anchor="ctr" wrap="square"/>
-          <a:lstStyle/>
-          <a:p>
-            <a:pPr algn="ctr">
-              <a:spcBef>
-                <a:spcPts val="13000"/>
-              </a:spcBef>
-              <a:defRPr sz="1400">
-                <a:solidFill>
-                  <a:srgbClr val="6B7280"/>
-                </a:solidFill>
-                <a:latin typeface="Calibri"/>
-              </a:defRPr>
-            </a:pPr>
-            <a:r>
-              <a:t>[Chart 3.1 — Top-10 Concentration Ratio Timeline]</a:t>
-            </a:r>
-          </a:p>
-        </p:txBody>
-      </p:sp>
-      <p:sp>
-        <p:nvSpPr>
-          <p:cNvPr id="4" name="Rounded Rectangle 3"/>
-          <p:cNvSpPr/>
-          <p:nvPr/>
-        </p:nvSpPr>
+          <a:prstGeom prst="rect">
+            <a:avLst/>
+          </a:prstGeom>
+        </p:spPr>
+      </p:pic>
+      <p:pic>
+        <p:nvPicPr>
+          <p:cNvPr id="4" name="Picture 3" descr="chart_3_2_spy_vs_rsp.png"/>
+          <p:cNvPicPr>
+            <a:picLocks noChangeAspect="1"/>
+          </p:cNvPicPr>
+          <p:nvPr/>
+        </p:nvPicPr>
+        <p:blipFill>
+          <a:blip r:embed="rId3"/>
+          <a:stretch>
+            <a:fillRect/>
+          </a:stretch>
+        </p:blipFill>
         <p:spPr>
           <a:xfrm>
             <a:off x="7589520" y="1188720"/>
             <a:ext cx="4114800" cy="2194560"/>
           </a:xfrm>
-          <a:prstGeom prst="roundRect">
-            <a:avLst/>
-          </a:prstGeom>
-          <a:solidFill>
-            <a:srgbClr val="0D1117"/>
-          </a:solidFill>
-          <a:ln w="12700">
-            <a:solidFill>
-              <a:srgbClr val="374151"/>
-            </a:solidFill>
-          </a:ln>
-          <a:effectLst/>
-        </p:spPr>
-        <p:style>
-          <a:lnRef idx="1">
-            <a:schemeClr val="accent1"/>
-          </a:lnRef>
-          <a:fillRef idx="3">
-            <a:schemeClr val="accent1"/>
-          </a:fillRef>
-          <a:effectRef idx="2">
-            <a:schemeClr val="accent1"/>
-          </a:effectRef>
-          <a:fontRef idx="minor">
-            <a:schemeClr val="lt1"/>
-          </a:fontRef>
-        </p:style>
-        <p:txBody>
-          <a:bodyPr rtlCol="0" anchor="ctr" wrap="square"/>
-          <a:lstStyle/>
-          <a:p>
-            <a:pPr algn="ctr">
-              <a:spcBef>
-                <a:spcPts val="6000"/>
-              </a:spcBef>
-              <a:defRPr sz="1400">
-                <a:solidFill>
-                  <a:srgbClr val="6B7280"/>
-                </a:solidFill>
-                <a:latin typeface="Calibri"/>
-              </a:defRPr>
-            </a:pPr>
-            <a:r>
-              <a:t>[Chart 3.2 — SPY vs RSP Spread]</a:t>
-            </a:r>
-          </a:p>
-        </p:txBody>
-      </p:sp>
+          <a:prstGeom prst="rect">
+            <a:avLst/>
+          </a:prstGeom>
+        </p:spPr>
+      </p:pic>
       <p:sp>
         <p:nvSpPr>
           <p:cNvPr id="5" name="Rounded Rectangle 4"/>
@@ -9324,124 +9079,54 @@
           </a:p>
         </p:txBody>
       </p:sp>
-      <p:sp>
-        <p:nvSpPr>
-          <p:cNvPr id="3" name="Rounded Rectangle 2"/>
-          <p:cNvSpPr/>
-          <p:nvPr/>
-        </p:nvSpPr>
+      <p:pic>
+        <p:nvPicPr>
+          <p:cNvPr id="3" name="Picture 2" descr="chart_5_1_ai_mentions.png"/>
+          <p:cNvPicPr>
+            <a:picLocks noChangeAspect="1"/>
+          </p:cNvPicPr>
+          <p:nvPr/>
+        </p:nvPicPr>
+        <p:blipFill>
+          <a:blip r:embed="rId2"/>
+          <a:stretch>
+            <a:fillRect/>
+          </a:stretch>
+        </p:blipFill>
         <p:spPr>
           <a:xfrm>
             <a:off x="457200" y="1188720"/>
             <a:ext cx="5486400" cy="4754880"/>
           </a:xfrm>
-          <a:prstGeom prst="roundRect">
-            <a:avLst/>
-          </a:prstGeom>
-          <a:solidFill>
-            <a:srgbClr val="0D1117"/>
-          </a:solidFill>
-          <a:ln w="12700">
-            <a:solidFill>
-              <a:srgbClr val="374151"/>
-            </a:solidFill>
-          </a:ln>
-          <a:effectLst/>
-        </p:spPr>
-        <p:style>
-          <a:lnRef idx="1">
-            <a:schemeClr val="accent1"/>
-          </a:lnRef>
-          <a:fillRef idx="3">
-            <a:schemeClr val="accent1"/>
-          </a:fillRef>
-          <a:effectRef idx="2">
-            <a:schemeClr val="accent1"/>
-          </a:effectRef>
-          <a:fontRef idx="minor">
-            <a:schemeClr val="lt1"/>
-          </a:fontRef>
-        </p:style>
-        <p:txBody>
-          <a:bodyPr rtlCol="0" anchor="ctr" wrap="square"/>
-          <a:lstStyle/>
-          <a:p>
-            <a:pPr algn="ctr">
-              <a:spcBef>
-                <a:spcPts val="13000"/>
-              </a:spcBef>
-              <a:defRPr sz="1400">
-                <a:solidFill>
-                  <a:srgbClr val="6B7280"/>
-                </a:solidFill>
-                <a:latin typeface="Calibri"/>
-              </a:defRPr>
-            </a:pPr>
-            <a:r>
-              <a:t>[Chart 5.1 — AI Mentions in Earnings Calls Over Time]</a:t>
-            </a:r>
-          </a:p>
-        </p:txBody>
-      </p:sp>
-      <p:sp>
-        <p:nvSpPr>
-          <p:cNvPr id="4" name="Rounded Rectangle 3"/>
-          <p:cNvSpPr/>
-          <p:nvPr/>
-        </p:nvSpPr>
+          <a:prstGeom prst="rect">
+            <a:avLst/>
+          </a:prstGeom>
+        </p:spPr>
+      </p:pic>
+      <p:pic>
+        <p:nvPicPr>
+          <p:cNvPr id="4" name="Picture 3" descr="chart_5_2_hype_vs_specificity.png"/>
+          <p:cNvPicPr>
+            <a:picLocks noChangeAspect="1"/>
+          </p:cNvPicPr>
+          <p:nvPr/>
+        </p:nvPicPr>
+        <p:blipFill>
+          <a:blip r:embed="rId3"/>
+          <a:stretch>
+            <a:fillRect/>
+          </a:stretch>
+        </p:blipFill>
         <p:spPr>
           <a:xfrm>
             <a:off x="6217920" y="1188720"/>
             <a:ext cx="5486400" cy="4754880"/>
           </a:xfrm>
-          <a:prstGeom prst="roundRect">
-            <a:avLst/>
-          </a:prstGeom>
-          <a:solidFill>
-            <a:srgbClr val="0D1117"/>
-          </a:solidFill>
-          <a:ln w="12700">
-            <a:solidFill>
-              <a:srgbClr val="374151"/>
-            </a:solidFill>
-          </a:ln>
-          <a:effectLst/>
-        </p:spPr>
-        <p:style>
-          <a:lnRef idx="1">
-            <a:schemeClr val="accent1"/>
-          </a:lnRef>
-          <a:fillRef idx="3">
-            <a:schemeClr val="accent1"/>
-          </a:fillRef>
-          <a:effectRef idx="2">
-            <a:schemeClr val="accent1"/>
-          </a:effectRef>
-          <a:fontRef idx="minor">
-            <a:schemeClr val="lt1"/>
-          </a:fontRef>
-        </p:style>
-        <p:txBody>
-          <a:bodyPr rtlCol="0" anchor="ctr" wrap="square"/>
-          <a:lstStyle/>
-          <a:p>
-            <a:pPr algn="ctr">
-              <a:spcBef>
-                <a:spcPts val="13000"/>
-              </a:spcBef>
-              <a:defRPr sz="1400">
-                <a:solidFill>
-                  <a:srgbClr val="6B7280"/>
-                </a:solidFill>
-                <a:latin typeface="Calibri"/>
-              </a:defRPr>
-            </a:pPr>
-            <a:r>
-              <a:t>[Chart 5.2 — Hype Score vs Revenue Specificity Scatter]</a:t>
-            </a:r>
-          </a:p>
-        </p:txBody>
-      </p:sp>
+          <a:prstGeom prst="rect">
+            <a:avLst/>
+          </a:prstGeom>
+        </p:spPr>
+      </p:pic>
       <p:sp>
         <p:nvSpPr>
           <p:cNvPr id="5" name="TextBox 4"/>
@@ -9540,65 +9225,30 @@
           </a:p>
         </p:txBody>
       </p:sp>
-      <p:sp>
-        <p:nvSpPr>
-          <p:cNvPr id="3" name="Rounded Rectangle 2"/>
-          <p:cNvSpPr/>
-          <p:nvPr/>
-        </p:nvSpPr>
+      <p:pic>
+        <p:nvPicPr>
+          <p:cNvPr id="3" name="Picture 2" descr="chart_4_5_macro_dashboard.png"/>
+          <p:cNvPicPr>
+            <a:picLocks noChangeAspect="1"/>
+          </p:cNvPicPr>
+          <p:nvPr/>
+        </p:nvPicPr>
+        <p:blipFill>
+          <a:blip r:embed="rId2"/>
+          <a:stretch>
+            <a:fillRect/>
+          </a:stretch>
+        </p:blipFill>
         <p:spPr>
           <a:xfrm>
             <a:off x="457200" y="1188720"/>
             <a:ext cx="11247120" cy="4754880"/>
           </a:xfrm>
-          <a:prstGeom prst="roundRect">
-            <a:avLst/>
-          </a:prstGeom>
-          <a:solidFill>
-            <a:srgbClr val="0D1117"/>
-          </a:solidFill>
-          <a:ln w="12700">
-            <a:solidFill>
-              <a:srgbClr val="374151"/>
-            </a:solidFill>
-          </a:ln>
-          <a:effectLst/>
-        </p:spPr>
-        <p:style>
-          <a:lnRef idx="1">
-            <a:schemeClr val="accent1"/>
-          </a:lnRef>
-          <a:fillRef idx="3">
-            <a:schemeClr val="accent1"/>
-          </a:fillRef>
-          <a:effectRef idx="2">
-            <a:schemeClr val="accent1"/>
-          </a:effectRef>
-          <a:fontRef idx="minor">
-            <a:schemeClr val="lt1"/>
-          </a:fontRef>
-        </p:style>
-        <p:txBody>
-          <a:bodyPr rtlCol="0" anchor="ctr" wrap="square"/>
-          <a:lstStyle/>
-          <a:p>
-            <a:pPr algn="ctr">
-              <a:spcBef>
-                <a:spcPts val="13000"/>
-              </a:spcBef>
-              <a:defRPr sz="1400">
-                <a:solidFill>
-                  <a:srgbClr val="6B7280"/>
-                </a:solidFill>
-                <a:latin typeface="Calibri"/>
-              </a:defRPr>
-            </a:pPr>
-            <a:r>
-              <a:t>[Chart 4.5 — Macro Dashboard: 2x3 Small Multiples (Fed Funds, M2, Yield Curve, Credit Spreads, CPI, GDP)]</a:t>
-            </a:r>
-          </a:p>
-        </p:txBody>
-      </p:sp>
+          <a:prstGeom prst="rect">
+            <a:avLst/>
+          </a:prstGeom>
+        </p:spPr>
+      </p:pic>
       <p:sp>
         <p:nvSpPr>
           <p:cNvPr id="4" name="TextBox 3"/>

</xml_diff>

<commit_message>
Fix slide chart images: preserve aspect ratio, center within bounds
Images were being stretched to fill placeholder boxes. Now uses
_fit_image() which calculates the correct dimensions to maintain
the native aspect ratio and centers the image within the bounding box.

All 10 chart images verified: no overflow, no stretching.

Co-Authored-By: Claude Opus 4.6 (1M context) <noreply@anthropic.com>
</commit_message>
<xml_diff>
--- a/submissions/2kim_finance_slides.pptx
+++ b/submissions/2kim_finance_slides.pptx
@@ -3413,8 +3413,8 @@
         </p:blipFill>
         <p:spPr>
           <a:xfrm>
-            <a:off x="457200" y="1188720"/>
-            <a:ext cx="7772400" cy="4754880"/>
+            <a:off x="457200" y="1623060"/>
+            <a:ext cx="7772400" cy="3886200"/>
           </a:xfrm>
           <a:prstGeom prst="rect">
             <a:avLst/>
@@ -3977,8 +3977,8 @@
         </p:blipFill>
         <p:spPr>
           <a:xfrm>
-            <a:off x="457200" y="1097280"/>
-            <a:ext cx="11247120" cy="2286000"/>
+            <a:off x="3794760" y="1097280"/>
+            <a:ext cx="4572000" cy="2286000"/>
           </a:xfrm>
           <a:prstGeom prst="rect">
             <a:avLst/>
@@ -6361,8 +6361,8 @@
         </p:blipFill>
         <p:spPr>
           <a:xfrm>
-            <a:off x="457200" y="1188720"/>
-            <a:ext cx="11247120" cy="4754880"/>
+            <a:off x="1854200" y="1188720"/>
+            <a:ext cx="8453120" cy="4754880"/>
           </a:xfrm>
           <a:prstGeom prst="rect">
             <a:avLst/>
@@ -8001,8 +8001,8 @@
         </p:blipFill>
         <p:spPr>
           <a:xfrm>
-            <a:off x="457200" y="1188720"/>
-            <a:ext cx="7315200" cy="4754880"/>
+            <a:off x="457200" y="1508760"/>
+            <a:ext cx="7315200" cy="4114800"/>
           </a:xfrm>
           <a:prstGeom prst="rect">
             <a:avLst/>
@@ -8421,8 +8421,8 @@
         </p:blipFill>
         <p:spPr>
           <a:xfrm>
-            <a:off x="457200" y="1188720"/>
-            <a:ext cx="11247120" cy="3657600"/>
+            <a:off x="2829560" y="1188720"/>
+            <a:ext cx="6502400" cy="3657600"/>
           </a:xfrm>
           <a:prstGeom prst="rect">
             <a:avLst/>
@@ -8687,8 +8687,8 @@
         </p:blipFill>
         <p:spPr>
           <a:xfrm>
-            <a:off x="457200" y="1188720"/>
-            <a:ext cx="6858000" cy="4754880"/>
+            <a:off x="457200" y="1637347"/>
+            <a:ext cx="6858000" cy="3857625"/>
           </a:xfrm>
           <a:prstGeom prst="rect">
             <a:avLst/>
@@ -8711,8 +8711,8 @@
         </p:blipFill>
         <p:spPr>
           <a:xfrm>
-            <a:off x="7589520" y="1188720"/>
-            <a:ext cx="4114800" cy="2194560"/>
+            <a:off x="7696200" y="1188720"/>
+            <a:ext cx="3901440" cy="2194560"/>
           </a:xfrm>
           <a:prstGeom prst="rect">
             <a:avLst/>
@@ -9095,8 +9095,8 @@
         </p:blipFill>
         <p:spPr>
           <a:xfrm>
-            <a:off x="457200" y="1188720"/>
-            <a:ext cx="5486400" cy="4754880"/>
+            <a:off x="457200" y="2023110"/>
+            <a:ext cx="5486400" cy="3086100"/>
           </a:xfrm>
           <a:prstGeom prst="rect">
             <a:avLst/>
@@ -9119,8 +9119,8 @@
         </p:blipFill>
         <p:spPr>
           <a:xfrm>
-            <a:off x="6217920" y="1188720"/>
-            <a:ext cx="5486400" cy="4754880"/>
+            <a:off x="6217920" y="2023110"/>
+            <a:ext cx="5486400" cy="3086100"/>
           </a:xfrm>
           <a:prstGeom prst="rect">
             <a:avLst/>
@@ -9241,8 +9241,8 @@
         </p:blipFill>
         <p:spPr>
           <a:xfrm>
-            <a:off x="457200" y="1188720"/>
-            <a:ext cx="11247120" cy="4754880"/>
+            <a:off x="1854200" y="1188720"/>
+            <a:ext cx="8453120" cy="4754880"/>
           </a:xfrm>
           <a:prstGeom prst="rect">
             <a:avLst/>

</xml_diff>